<commit_message>
fix(ppt): 第9页标签 R3/R6/R7 改为 01/02/03
移除开发阶段内部规则编号，改为对受众有意义的序号。

🤖 Generated with [Qoder][https://qoder.com]
Change-Id: I8106562718c89459ad4bdf4300be5feeaae3a7c5
</commit_message>
<xml_diff>
--- a/ppt-build/LogPilot-项目介绍.pptx
+++ b/ppt-build/LogPilot-项目介绍.pptx
@@ -16742,7 +16742,7 @@
                 <a:ea typeface="Microsoft YaHei" pitchFamily="34" charset="-122"/>
                 <a:cs typeface="Microsoft YaHei" pitchFamily="34" charset="-120"/>
               </a:rPr>
-              <a:t>R3</a:t>
+              <a:t>01</a:t>
             </a:r>
             <a:endParaRPr lang="en-US" sz="2800" dirty="0"/>
           </a:p>
@@ -16965,7 +16965,7 @@
                 <a:ea typeface="Microsoft YaHei" pitchFamily="34" charset="-122"/>
                 <a:cs typeface="Microsoft YaHei" pitchFamily="34" charset="-120"/>
               </a:rPr>
-              <a:t>R6</a:t>
+              <a:t>02</a:t>
             </a:r>
             <a:endParaRPr lang="en-US" sz="2800" dirty="0"/>
           </a:p>
@@ -17188,7 +17188,7 @@
                 <a:ea typeface="Microsoft YaHei" pitchFamily="34" charset="-122"/>
                 <a:cs typeface="Microsoft YaHei" pitchFamily="34" charset="-120"/>
               </a:rPr>
-              <a:t>R7</a:t>
+              <a:t>03</a:t>
             </a:r>
             <a:endParaRPr lang="en-US" sz="2800" dirty="0"/>
           </a:p>

</xml_diff>